<commit_message>
Add cross-technique lens-table slide (how quantization re-opens the suppressed fact) to deck
Co-Authored-By: Claude Opus 4.8 <noreply@anthropic.com>
</commit_message>
<xml_diff>
--- a/deck/LeakLens.pptx
+++ b/deck/LeakLens.pptx
@@ -28,6 +28,7 @@
     <p:sldId id="276" r:id="rId27"/>
     <p:sldId id="277" r:id="rId28"/>
     <p:sldId id="278" r:id="rId29"/>
+    <p:sldId id="279" r:id="rId30"/>
   </p:sldIdLst>
   <p:sldSz cx="12191695" cy="6858000" type="screen4x3"/>
   <p:notesSz cx="6858000" cy="9144000"/>
@@ -5903,7 +5904,7 @@
                 </a:solidFill>
                 <a:latin typeface="Times New Roman"/>
               </a:rPr>
-              <a:t>3 · RESULT 2: FOUR MECHANISMS, FOUR RESPONSES</a:t>
+              <a:t>3 · RESULT 1: RE-OPENING, TECHNIQUE BY TECHNIQUE</a:t>
             </a:r>
           </a:p>
         </p:txBody>
@@ -5936,13 +5937,13 @@
               </a:spcAft>
             </a:pPr>
             <a:r>
-              <a:rPr sz="2500" b="1" i="0">
+              <a:rPr sz="2100" b="1" i="0">
                 <a:solidFill>
                   <a:srgbClr val="000000"/>
                 </a:solidFill>
                 <a:latin typeface="Times New Roman"/>
               </a:rPr>
-              <a:t>the internal readout explains who survives quantization</a:t>
+              <a:t>one fact, the logit-lens top token at every layer across quantization backends</a:t>
             </a:r>
           </a:p>
         </p:txBody>
@@ -5991,16 +5992,40 @@
           </a:p>
         </p:txBody>
       </p:sp>
-      <p:sp>
-        <p:nvSpPr>
-          <p:cNvPr id="5" name="TextBox 4"/>
+      <p:pic>
+        <p:nvPicPr>
+          <p:cNvPr id="5" name="Picture 4" descr="lenstable_quant_8b.png"/>
+          <p:cNvPicPr>
+            <a:picLocks noChangeAspect="1"/>
+          </p:cNvPicPr>
+          <p:nvPr/>
+        </p:nvPicPr>
+        <p:blipFill>
+          <a:blip r:embed="rId2"/>
+          <a:stretch>
+            <a:fillRect/>
+          </a:stretch>
+        </p:blipFill>
+        <p:spPr>
+          <a:xfrm>
+            <a:off x="1920286" y="1691640"/>
+            <a:ext cx="8351123" cy="4754880"/>
+          </a:xfrm>
+          <a:prstGeom prst="rect">
+            <a:avLst/>
+          </a:prstGeom>
+        </p:spPr>
+      </p:pic>
+      <p:sp>
+        <p:nvSpPr>
+          <p:cNvPr id="6" name="TextBox 5"/>
           <p:cNvSpPr txBox="1"/>
           <p:nvPr/>
         </p:nvSpPr>
         <p:spPr>
           <a:xfrm>
-            <a:off x="685800" y="1737360"/>
-            <a:ext cx="10789920" cy="4754879"/>
+            <a:off x="685800" y="6355080"/>
+            <a:ext cx="10789920" cy="411480"/>
           </a:xfrm>
           <a:prstGeom prst="rect">
             <a:avLst/>
@@ -6015,113 +6040,17 @@
           <a:p>
             <a:pPr algn="l">
               <a:spcAft>
-                <a:spcPts val="500"/>
-              </a:spcAft>
-            </a:pPr>
-            <a:r>
-              <a:rPr sz="1800" b="1" i="0">
-                <a:solidFill>
-                  <a:srgbClr val="000000"/>
-                </a:solidFill>
-                <a:latin typeface="Times New Roman"/>
-              </a:rPr>
-              <a:t>IDK</a:t>
-            </a:r>
-          </a:p>
-          <a:p>
-            <a:pPr algn="l">
-              <a:spcAft>
                 <a:spcPts val="600"/>
               </a:spcAft>
             </a:pPr>
             <a:r>
-              <a:rPr sz="1600" b="0" i="0">
-                <a:solidFill>
-                  <a:srgbClr val="1A1A1A"/>
-                </a:solidFill>
-                <a:latin typeface="Times New Roman"/>
-              </a:rPr>
-              <a:t>–  Redirects the OUTPUT ("I don't know") without disturbing the representation, so the token stays internally accessible throughout; quantization neither helps nor hurts.</a:t>
-            </a:r>
-          </a:p>
-          <a:p>
-            <a:pPr algn="l">
-              <a:spcAft>
-                <a:spcPts val="500"/>
-              </a:spcAft>
-            </a:pPr>
-            <a:r>
-              <a:rPr sz="1800" b="1" i="0">
-                <a:solidFill>
-                  <a:srgbClr val="000000"/>
-                </a:solidFill>
-                <a:latin typeface="Times New Roman"/>
-              </a:rPr>
-              <a:t>NPO</a:t>
-            </a:r>
-          </a:p>
-          <a:p>
-            <a:pPr algn="l">
-              <a:spcAft>
-                <a:spcPts val="600"/>
-              </a:spcAft>
-            </a:pPr>
-            <a:r>
-              <a:rPr sz="1600" b="0" i="0">
-                <a:solidFill>
-                  <a:srgbClr val="1A1A1A"/>
-                </a:solidFill>
-                <a:latin typeface="Times New Roman"/>
-              </a:rPr>
-              <a:t>–  Buries the fact deeply at fp16 but the representation is fragile: crude 4-bit RTN re-opens it (Result 1).</a:t>
-            </a:r>
-          </a:p>
-          <a:p>
-            <a:pPr algn="l">
-              <a:spcAft>
-                <a:spcPts val="500"/>
-              </a:spcAft>
-            </a:pPr>
-            <a:r>
-              <a:rPr sz="1800" b="1" i="0">
-                <a:solidFill>
-                  <a:srgbClr val="000000"/>
-                </a:solidFill>
-                <a:latin typeface="Times New Roman"/>
-              </a:rPr>
-              <a:t>RMU</a:t>
-            </a:r>
-          </a:p>
-          <a:p>
-            <a:pPr algn="l">
-              <a:spcAft>
-                <a:spcPts val="600"/>
-              </a:spcAft>
-            </a:pPr>
-            <a:r>
-              <a:rPr sz="1600" b="0" i="0">
-                <a:solidFill>
-                  <a:srgbClr val="1A1A1A"/>
-                </a:solidFill>
-                <a:latin typeface="Times New Roman"/>
-              </a:rPr>
-              <a:t>–  Scrambles the representation early and deep (the strongest suppression of the three); only mildly moved by quantization.</a:t>
-            </a:r>
-          </a:p>
-          <a:p>
-            <a:pPr algn="l">
-              <a:spcAft>
-                <a:spcPts val="600"/>
-              </a:spcAft>
-            </a:pPr>
-            <a:r>
-              <a:rPr sz="1600" b="0" i="0">
-                <a:solidFill>
-                  <a:srgbClr val="1A1A1A"/>
-                </a:solidFill>
-                <a:latin typeface="Times New Roman"/>
-              </a:rPr>
-              <a:t>–  The deployment-compression view reproduces the thesis mechanistic taxonomy (IDK surface, NPO late suppression, RMU deep scramble).</a:t>
+              <a:rPr sz="1200" b="0" i="1">
+                <a:solidFill>
+                  <a:srgbClr val="666666"/>
+                </a:solidFill>
+                <a:latin typeface="Times New Roman"/>
+              </a:rPr>
+              <a:t>Gold token stays buried under fp16, INT8 and NF4 (decodes garbage at high confidence) but climbs back to rank 3 - surfacing the answer at the deep layers - under crude 4-bit RTN. The same lens-table view from the thesis, now read across compression schemes.</a:t>
             </a:r>
           </a:p>
         </p:txBody>
@@ -6178,7 +6107,7 @@
                 </a:solidFill>
                 <a:latin typeface="Times New Roman"/>
               </a:rPr>
-              <a:t>3 · RESULT 3: THE CALIBRATION-SET ATTACK</a:t>
+              <a:t>3 · RESULT 2: FOUR MECHANISMS, FOUR RESPONSES</a:t>
             </a:r>
           </a:p>
         </p:txBody>
@@ -6217,7 +6146,7 @@
                 </a:solidFill>
                 <a:latin typeface="Times New Roman"/>
               </a:rPr>
-              <a:t>an honest null: calibration proximity barely moves recovery</a:t>
+              <a:t>the internal readout explains who survives quantization</a:t>
             </a:r>
           </a:p>
         </p:txBody>
@@ -6266,40 +6195,16 @@
           </a:p>
         </p:txBody>
       </p:sp>
-      <p:pic>
-        <p:nvPicPr>
-          <p:cNvPr id="5" name="Picture 4" descr="calibration_attack_8b.png"/>
-          <p:cNvPicPr>
-            <a:picLocks noChangeAspect="1"/>
-          </p:cNvPicPr>
-          <p:nvPr/>
-        </p:nvPicPr>
-        <p:blipFill>
-          <a:blip r:embed="rId2"/>
-          <a:stretch>
-            <a:fillRect/>
-          </a:stretch>
-        </p:blipFill>
-        <p:spPr>
-          <a:xfrm>
-            <a:off x="3158506" y="1691640"/>
-            <a:ext cx="5874683" cy="4114800"/>
-          </a:xfrm>
-          <a:prstGeom prst="rect">
-            <a:avLst/>
-          </a:prstGeom>
-        </p:spPr>
-      </p:pic>
-      <p:sp>
-        <p:nvSpPr>
-          <p:cNvPr id="6" name="TextBox 5"/>
+      <p:sp>
+        <p:nvSpPr>
+          <p:cNvPr id="5" name="TextBox 4"/>
           <p:cNvSpPr txBox="1"/>
           <p:nvPr/>
         </p:nvSpPr>
         <p:spPr>
           <a:xfrm>
-            <a:off x="685800" y="6355080"/>
-            <a:ext cx="10789920" cy="411480"/>
+            <a:off x="685800" y="1737360"/>
+            <a:ext cx="10789920" cy="4754879"/>
           </a:xfrm>
           <a:prstGeom prst="rect">
             <a:avLst/>
@@ -6314,17 +6219,113 @@
           <a:p>
             <a:pPr algn="l">
               <a:spcAft>
+                <a:spcPts val="500"/>
+              </a:spcAft>
+            </a:pPr>
+            <a:r>
+              <a:rPr sz="1800" b="1" i="0">
+                <a:solidFill>
+                  <a:srgbClr val="000000"/>
+                </a:solidFill>
+                <a:latin typeface="Times New Roman"/>
+              </a:rPr>
+              <a:t>IDK</a:t>
+            </a:r>
+          </a:p>
+          <a:p>
+            <a:pPr algn="l">
+              <a:spcAft>
                 <a:spcPts val="600"/>
               </a:spcAft>
             </a:pPr>
             <a:r>
-              <a:rPr sz="1200" b="0" i="1">
-                <a:solidFill>
-                  <a:srgbClr val="666666"/>
-                </a:solidFill>
-                <a:latin typeface="Times New Roman"/>
-              </a:rPr>
-              <a:t>Sweeping the AWQ calibration corpus generic -&gt; adjacent -&gt; forget moves recovery only 0.006 to 0.009, within noise at n=25. Not shown to be an attack surface. Reported as a null, not spun.</a:t>
+              <a:rPr sz="1600" b="0" i="0">
+                <a:solidFill>
+                  <a:srgbClr val="1A1A1A"/>
+                </a:solidFill>
+                <a:latin typeface="Times New Roman"/>
+              </a:rPr>
+              <a:t>–  Redirects the OUTPUT ("I don't know") without disturbing the representation, so the token stays internally accessible throughout; quantization neither helps nor hurts.</a:t>
+            </a:r>
+          </a:p>
+          <a:p>
+            <a:pPr algn="l">
+              <a:spcAft>
+                <a:spcPts val="500"/>
+              </a:spcAft>
+            </a:pPr>
+            <a:r>
+              <a:rPr sz="1800" b="1" i="0">
+                <a:solidFill>
+                  <a:srgbClr val="000000"/>
+                </a:solidFill>
+                <a:latin typeface="Times New Roman"/>
+              </a:rPr>
+              <a:t>NPO</a:t>
+            </a:r>
+          </a:p>
+          <a:p>
+            <a:pPr algn="l">
+              <a:spcAft>
+                <a:spcPts val="600"/>
+              </a:spcAft>
+            </a:pPr>
+            <a:r>
+              <a:rPr sz="1600" b="0" i="0">
+                <a:solidFill>
+                  <a:srgbClr val="1A1A1A"/>
+                </a:solidFill>
+                <a:latin typeface="Times New Roman"/>
+              </a:rPr>
+              <a:t>–  Buries the fact deeply at fp16 but the representation is fragile: crude 4-bit RTN re-opens it (Result 1).</a:t>
+            </a:r>
+          </a:p>
+          <a:p>
+            <a:pPr algn="l">
+              <a:spcAft>
+                <a:spcPts val="500"/>
+              </a:spcAft>
+            </a:pPr>
+            <a:r>
+              <a:rPr sz="1800" b="1" i="0">
+                <a:solidFill>
+                  <a:srgbClr val="000000"/>
+                </a:solidFill>
+                <a:latin typeface="Times New Roman"/>
+              </a:rPr>
+              <a:t>RMU</a:t>
+            </a:r>
+          </a:p>
+          <a:p>
+            <a:pPr algn="l">
+              <a:spcAft>
+                <a:spcPts val="600"/>
+              </a:spcAft>
+            </a:pPr>
+            <a:r>
+              <a:rPr sz="1600" b="0" i="0">
+                <a:solidFill>
+                  <a:srgbClr val="1A1A1A"/>
+                </a:solidFill>
+                <a:latin typeface="Times New Roman"/>
+              </a:rPr>
+              <a:t>–  Scrambles the representation early and deep (the strongest suppression of the three); only mildly moved by quantization.</a:t>
+            </a:r>
+          </a:p>
+          <a:p>
+            <a:pPr algn="l">
+              <a:spcAft>
+                <a:spcPts val="600"/>
+              </a:spcAft>
+            </a:pPr>
+            <a:r>
+              <a:rPr sz="1600" b="0" i="0">
+                <a:solidFill>
+                  <a:srgbClr val="1A1A1A"/>
+                </a:solidFill>
+                <a:latin typeface="Times New Roman"/>
+              </a:rPr>
+              <a:t>–  The deployment-compression view reproduces the thesis mechanistic taxonomy (IDK surface, NPO late suppression, RMU deep scramble).</a:t>
             </a:r>
           </a:p>
         </p:txBody>
@@ -6672,7 +6673,7 @@
                 </a:solidFill>
                 <a:latin typeface="Times New Roman"/>
               </a:rPr>
-              <a:t>3 · RESULT 4: THE REAL-GPTQ CROSS-CHECK</a:t>
+              <a:t>3 · RESULT 3: THE CALIBRATION-SET ATTACK</a:t>
             </a:r>
           </a:p>
         </p:txBody>
@@ -6711,7 +6712,7 @@
                 </a:solidFill>
                 <a:latin typeface="Times New Roman"/>
               </a:rPr>
-              <a:t>the decisive test could not be run in this environment</a:t>
+              <a:t>an honest null: calibration proximity barely moves recovery</a:t>
             </a:r>
           </a:p>
         </p:txBody>
@@ -6760,16 +6761,40 @@
           </a:p>
         </p:txBody>
       </p:sp>
-      <p:sp>
-        <p:nvSpPr>
-          <p:cNvPr id="5" name="TextBox 4"/>
+      <p:pic>
+        <p:nvPicPr>
+          <p:cNvPr id="5" name="Picture 4" descr="calibration_attack_8b.png"/>
+          <p:cNvPicPr>
+            <a:picLocks noChangeAspect="1"/>
+          </p:cNvPicPr>
+          <p:nvPr/>
+        </p:nvPicPr>
+        <p:blipFill>
+          <a:blip r:embed="rId2"/>
+          <a:stretch>
+            <a:fillRect/>
+          </a:stretch>
+        </p:blipFill>
+        <p:spPr>
+          <a:xfrm>
+            <a:off x="3158506" y="1691640"/>
+            <a:ext cx="5874683" cy="4114800"/>
+          </a:xfrm>
+          <a:prstGeom prst="rect">
+            <a:avLst/>
+          </a:prstGeom>
+        </p:spPr>
+      </p:pic>
+      <p:sp>
+        <p:nvSpPr>
+          <p:cNvPr id="6" name="TextBox 5"/>
           <p:cNvSpPr txBox="1"/>
           <p:nvPr/>
         </p:nvSpPr>
         <p:spPr>
           <a:xfrm>
-            <a:off x="685800" y="1737360"/>
-            <a:ext cx="10789920" cy="4754879"/>
+            <a:off x="685800" y="6355080"/>
+            <a:ext cx="10789920" cy="411480"/>
           </a:xfrm>
           <a:prstGeom prst="rect">
             <a:avLst/>
@@ -6784,81 +6809,17 @@
           <a:p>
             <a:pPr algn="l">
               <a:spcAft>
-                <a:spcPts val="800"/>
-              </a:spcAft>
-            </a:pPr>
-            <a:r>
-              <a:rPr sz="1600" b="0" i="0">
-                <a:solidFill>
-                  <a:srgbClr val="1A1A1A"/>
-                </a:solidFill>
-                <a:latin typeface="Times New Roman"/>
-              </a:rPr>
-              <a:t>–  We wired a real GPTQ backend (gptqmodel, desc_act, calibration = the swept corpus) as the decisive, more calibration-sensitive test.</a:t>
-            </a:r>
-          </a:p>
-          <a:p>
-            <a:pPr algn="l">
-              <a:spcAft>
-                <a:spcPts val="500"/>
-              </a:spcAft>
-            </a:pPr>
-            <a:r>
-              <a:rPr sz="1800" b="1" i="0">
-                <a:solidFill>
-                  <a:srgbClr val="000000"/>
-                </a:solidFill>
-                <a:latin typeface="Times New Roman"/>
-              </a:rPr>
-              <a:t>What happened</a:t>
-            </a:r>
-          </a:p>
-          <a:p>
-            <a:pPr algn="l">
-              <a:spcAft>
-                <a:spcPts val="800"/>
-              </a:spcAft>
-            </a:pPr>
-            <a:r>
-              <a:rPr sz="1600" b="0" i="0">
-                <a:solidFill>
-                  <a:srgbClr val="1A1A1A"/>
-                </a:solidFill>
-                <a:latin typeface="Times New Roman"/>
-              </a:rPr>
-              <a:t>–  GPTQ QUANTIZES successfully, but the packed model's forward pass crashes in gptqmodel's fallback kernel, an incompatibility with this environment's bleeding-edge Transformers 5.14 / Torch 2.11 (no optimized CUDA kernels available). Three successive fixes each advanced further; the last failure is internal to the library.</a:t>
-            </a:r>
-          </a:p>
-          <a:p>
-            <a:pPr algn="l">
-              <a:spcAft>
-                <a:spcPts val="500"/>
-              </a:spcAft>
-            </a:pPr>
-            <a:r>
-              <a:rPr sz="1800" b="1" i="0">
-                <a:solidFill>
-                  <a:srgbClr val="000000"/>
-                </a:solidFill>
-                <a:latin typeface="Times New Roman"/>
-              </a:rPr>
-              <a:t>Consequence, stated plainly</a:t>
-            </a:r>
-          </a:p>
-          <a:p>
-            <a:pPr algn="l">
-              <a:spcAft>
-                <a:spcPts val="800"/>
-              </a:spcAft>
-            </a:pPr>
-            <a:r>
-              <a:rPr sz="1600" b="0" i="0">
-                <a:solidFill>
-                  <a:srgbClr val="1A1A1A"/>
-                </a:solidFill>
-                <a:latin typeface="Times New Roman"/>
-              </a:rPr>
-              <a:t>–  The GPTQ cross-check is unresolved here, so the calibration-attack question stays open. The firm result LeakLens ships is the backend-dependent recovery of Result 1.</a:t>
+                <a:spcPts val="600"/>
+              </a:spcAft>
+            </a:pPr>
+            <a:r>
+              <a:rPr sz="1200" b="0" i="1">
+                <a:solidFill>
+                  <a:srgbClr val="666666"/>
+                </a:solidFill>
+                <a:latin typeface="Times New Roman"/>
+              </a:rPr>
+              <a:t>Sweeping the AWQ calibration corpus generic -&gt; adjacent -&gt; forget moves recovery only 0.006 to 0.009, within noise at n=25. Not shown to be an attack surface. Reported as a null, not spun.</a:t>
             </a:r>
           </a:p>
         </p:txBody>
@@ -6883,14 +6844,92 @@
       <p:grpSpPr/>
       <p:sp>
         <p:nvSpPr>
-          <p:cNvPr id="2" name="Rectangle 1"/>
+          <p:cNvPr id="2" name="TextBox 1"/>
+          <p:cNvSpPr txBox="1"/>
+          <p:nvPr/>
+        </p:nvSpPr>
+        <p:spPr>
+          <a:xfrm>
+            <a:off x="640080" y="384048"/>
+            <a:ext cx="10972800" cy="457200"/>
+          </a:xfrm>
+          <a:prstGeom prst="rect">
+            <a:avLst/>
+          </a:prstGeom>
+          <a:noFill/>
+        </p:spPr>
+        <p:txBody>
+          <a:bodyPr wrap="square" anchor="t">
+            <a:spAutoFit/>
+          </a:bodyPr>
+          <a:lstStyle/>
+          <a:p>
+            <a:pPr algn="l">
+              <a:spcAft>
+                <a:spcPts val="200"/>
+              </a:spcAft>
+            </a:pPr>
+            <a:r>
+              <a:rPr sz="1300" b="1" i="0">
+                <a:solidFill>
+                  <a:srgbClr val="666666"/>
+                </a:solidFill>
+                <a:latin typeface="Times New Roman"/>
+              </a:rPr>
+              <a:t>3 · RESULT 4: THE REAL-GPTQ CROSS-CHECK</a:t>
+            </a:r>
+          </a:p>
+        </p:txBody>
+      </p:sp>
+      <p:sp>
+        <p:nvSpPr>
+          <p:cNvPr id="3" name="TextBox 2"/>
+          <p:cNvSpPr txBox="1"/>
+          <p:nvPr/>
+        </p:nvSpPr>
+        <p:spPr>
+          <a:xfrm>
+            <a:off x="640080" y="749808"/>
+            <a:ext cx="11155680" cy="658368"/>
+          </a:xfrm>
+          <a:prstGeom prst="rect">
+            <a:avLst/>
+          </a:prstGeom>
+          <a:noFill/>
+        </p:spPr>
+        <p:txBody>
+          <a:bodyPr wrap="square" anchor="t">
+            <a:spAutoFit/>
+          </a:bodyPr>
+          <a:lstStyle/>
+          <a:p>
+            <a:pPr algn="l">
+              <a:spcAft>
+                <a:spcPts val="600"/>
+              </a:spcAft>
+            </a:pPr>
+            <a:r>
+              <a:rPr sz="2500" b="1" i="0">
+                <a:solidFill>
+                  <a:srgbClr val="000000"/>
+                </a:solidFill>
+                <a:latin typeface="Times New Roman"/>
+              </a:rPr>
+              <a:t>the decisive test could not be run in this environment</a:t>
+            </a:r>
+          </a:p>
+        </p:txBody>
+      </p:sp>
+      <p:sp>
+        <p:nvSpPr>
+          <p:cNvPr id="4" name="Rectangle 3"/>
           <p:cNvSpPr/>
           <p:nvPr/>
         </p:nvSpPr>
         <p:spPr>
           <a:xfrm>
-            <a:off x="0" y="2743200"/>
-            <a:ext cx="12191695" cy="25400"/>
+            <a:off x="658368" y="1481328"/>
+            <a:ext cx="10972800" cy="17780"/>
           </a:xfrm>
           <a:prstGeom prst="rect">
             <a:avLst/>
@@ -6927,14 +6966,14 @@
       </p:sp>
       <p:sp>
         <p:nvSpPr>
-          <p:cNvPr id="3" name="TextBox 2"/>
+          <p:cNvPr id="5" name="TextBox 4"/>
           <p:cNvSpPr txBox="1"/>
           <p:nvPr/>
         </p:nvSpPr>
         <p:spPr>
           <a:xfrm>
-            <a:off x="914400" y="1828800"/>
-            <a:ext cx="10332720" cy="548640"/>
+            <a:off x="685800" y="1737360"/>
+            <a:ext cx="10789920" cy="4754879"/>
           </a:xfrm>
           <a:prstGeom prst="rect">
             <a:avLst/>
@@ -6949,95 +6988,81 @@
           <a:p>
             <a:pPr algn="l">
               <a:spcAft>
-                <a:spcPts val="600"/>
-              </a:spcAft>
-            </a:pPr>
-            <a:r>
-              <a:rPr sz="1300" b="1" i="0">
-                <a:solidFill>
-                  <a:srgbClr val="666666"/>
-                </a:solidFill>
-                <a:latin typeface="Times New Roman"/>
-              </a:rPr>
-              <a:t>PART IV</a:t>
-            </a:r>
-          </a:p>
-        </p:txBody>
-      </p:sp>
-      <p:sp>
-        <p:nvSpPr>
-          <p:cNvPr id="4" name="TextBox 3"/>
-          <p:cNvSpPr txBox="1"/>
-          <p:nvPr/>
-        </p:nvSpPr>
-        <p:spPr>
-          <a:xfrm>
-            <a:off x="914400" y="2194560"/>
-            <a:ext cx="10332720" cy="822960"/>
-          </a:xfrm>
-          <a:prstGeom prst="rect">
-            <a:avLst/>
-          </a:prstGeom>
-          <a:noFill/>
-        </p:spPr>
-        <p:txBody>
-          <a:bodyPr wrap="square" anchor="t">
-            <a:spAutoFit/>
-          </a:bodyPr>
-          <a:lstStyle/>
-          <a:p>
-            <a:pPr algn="l">
-              <a:spcAft>
-                <a:spcPts val="600"/>
-              </a:spcAft>
-            </a:pPr>
-            <a:r>
-              <a:rPr sz="3400" b="1" i="0">
+                <a:spcPts val="800"/>
+              </a:spcAft>
+            </a:pPr>
+            <a:r>
+              <a:rPr sz="1600" b="0" i="0">
+                <a:solidFill>
+                  <a:srgbClr val="1A1A1A"/>
+                </a:solidFill>
+                <a:latin typeface="Times New Roman"/>
+              </a:rPr>
+              <a:t>–  We wired a real GPTQ backend (gptqmodel, desc_act, calibration = the swept corpus) as the decisive, more calibration-sensitive test.</a:t>
+            </a:r>
+          </a:p>
+          <a:p>
+            <a:pPr algn="l">
+              <a:spcAft>
+                <a:spcPts val="500"/>
+              </a:spcAft>
+            </a:pPr>
+            <a:r>
+              <a:rPr sz="1800" b="1" i="0">
                 <a:solidFill>
                   <a:srgbClr val="000000"/>
                 </a:solidFill>
                 <a:latin typeface="Times New Roman"/>
               </a:rPr>
-              <a:t>Takeaways</a:t>
-            </a:r>
-          </a:p>
-        </p:txBody>
-      </p:sp>
-      <p:sp>
-        <p:nvSpPr>
-          <p:cNvPr id="5" name="TextBox 4"/>
-          <p:cNvSpPr txBox="1"/>
-          <p:nvPr/>
-        </p:nvSpPr>
-        <p:spPr>
-          <a:xfrm>
-            <a:off x="914400" y="2926080"/>
-            <a:ext cx="10332720" cy="731520"/>
-          </a:xfrm>
-          <a:prstGeom prst="rect">
-            <a:avLst/>
-          </a:prstGeom>
-          <a:noFill/>
-        </p:spPr>
-        <p:txBody>
-          <a:bodyPr wrap="square" anchor="t">
-            <a:spAutoFit/>
-          </a:bodyPr>
-          <a:lstStyle/>
-          <a:p>
-            <a:pPr algn="l">
-              <a:spcAft>
-                <a:spcPts val="600"/>
-              </a:spcAft>
-            </a:pPr>
-            <a:r>
-              <a:rPr sz="1800" b="0" i="1">
-                <a:solidFill>
-                  <a:srgbClr val="666666"/>
-                </a:solidFill>
-                <a:latin typeface="Times New Roman"/>
-              </a:rPr>
-              <a:t>the complete story, and what is firm vs open</a:t>
+              <a:t>What happened</a:t>
+            </a:r>
+          </a:p>
+          <a:p>
+            <a:pPr algn="l">
+              <a:spcAft>
+                <a:spcPts val="800"/>
+              </a:spcAft>
+            </a:pPr>
+            <a:r>
+              <a:rPr sz="1600" b="0" i="0">
+                <a:solidFill>
+                  <a:srgbClr val="1A1A1A"/>
+                </a:solidFill>
+                <a:latin typeface="Times New Roman"/>
+              </a:rPr>
+              <a:t>–  GPTQ QUANTIZES successfully, but the packed model's forward pass crashes in gptqmodel's fallback kernel, an incompatibility with this environment's bleeding-edge Transformers 5.14 / Torch 2.11 (no optimized CUDA kernels available). Three successive fixes each advanced further; the last failure is internal to the library.</a:t>
+            </a:r>
+          </a:p>
+          <a:p>
+            <a:pPr algn="l">
+              <a:spcAft>
+                <a:spcPts val="500"/>
+              </a:spcAft>
+            </a:pPr>
+            <a:r>
+              <a:rPr sz="1800" b="1" i="0">
+                <a:solidFill>
+                  <a:srgbClr val="000000"/>
+                </a:solidFill>
+                <a:latin typeface="Times New Roman"/>
+              </a:rPr>
+              <a:t>Consequence, stated plainly</a:t>
+            </a:r>
+          </a:p>
+          <a:p>
+            <a:pPr algn="l">
+              <a:spcAft>
+                <a:spcPts val="800"/>
+              </a:spcAft>
+            </a:pPr>
+            <a:r>
+              <a:rPr sz="1600" b="0" i="0">
+                <a:solidFill>
+                  <a:srgbClr val="1A1A1A"/>
+                </a:solidFill>
+                <a:latin typeface="Times New Roman"/>
+              </a:rPr>
+              <a:t>–  The GPTQ cross-check is unresolved here, so the calibration-attack question stays open. The firm result LeakLens ships is the backend-dependent recovery of Result 1.</a:t>
             </a:r>
           </a:p>
         </p:txBody>
@@ -7062,92 +7087,14 @@
       <p:grpSpPr/>
       <p:sp>
         <p:nvSpPr>
-          <p:cNvPr id="2" name="TextBox 1"/>
-          <p:cNvSpPr txBox="1"/>
-          <p:nvPr/>
-        </p:nvSpPr>
-        <p:spPr>
-          <a:xfrm>
-            <a:off x="640080" y="384048"/>
-            <a:ext cx="10972800" cy="457200"/>
-          </a:xfrm>
-          <a:prstGeom prst="rect">
-            <a:avLst/>
-          </a:prstGeom>
-          <a:noFill/>
-        </p:spPr>
-        <p:txBody>
-          <a:bodyPr wrap="square" anchor="t">
-            <a:spAutoFit/>
-          </a:bodyPr>
-          <a:lstStyle/>
-          <a:p>
-            <a:pPr algn="l">
-              <a:spcAft>
-                <a:spcPts val="200"/>
-              </a:spcAft>
-            </a:pPr>
-            <a:r>
-              <a:rPr sz="1300" b="1" i="0">
-                <a:solidFill>
-                  <a:srgbClr val="666666"/>
-                </a:solidFill>
-                <a:latin typeface="Times New Roman"/>
-              </a:rPr>
-              <a:t>4 · LIMITATIONS</a:t>
-            </a:r>
-          </a:p>
-        </p:txBody>
-      </p:sp>
-      <p:sp>
-        <p:nvSpPr>
-          <p:cNvPr id="3" name="TextBox 2"/>
-          <p:cNvSpPr txBox="1"/>
-          <p:nvPr/>
-        </p:nvSpPr>
-        <p:spPr>
-          <a:xfrm>
-            <a:off x="640080" y="749808"/>
-            <a:ext cx="11155680" cy="658368"/>
-          </a:xfrm>
-          <a:prstGeom prst="rect">
-            <a:avLst/>
-          </a:prstGeom>
-          <a:noFill/>
-        </p:spPr>
-        <p:txBody>
-          <a:bodyPr wrap="square" anchor="t">
-            <a:spAutoFit/>
-          </a:bodyPr>
-          <a:lstStyle/>
-          <a:p>
-            <a:pPr algn="l">
-              <a:spcAft>
-                <a:spcPts val="600"/>
-              </a:spcAft>
-            </a:pPr>
-            <a:r>
-              <a:rPr sz="3000" b="1" i="0">
-                <a:solidFill>
-                  <a:srgbClr val="000000"/>
-                </a:solidFill>
-                <a:latin typeface="Times New Roman"/>
-              </a:rPr>
-              <a:t>stated honestly</a:t>
-            </a:r>
-          </a:p>
-        </p:txBody>
-      </p:sp>
-      <p:sp>
-        <p:nvSpPr>
-          <p:cNvPr id="4" name="Rectangle 3"/>
+          <p:cNvPr id="2" name="Rectangle 1"/>
           <p:cNvSpPr/>
           <p:nvPr/>
         </p:nvSpPr>
         <p:spPr>
           <a:xfrm>
-            <a:off x="658368" y="1481328"/>
-            <a:ext cx="10972800" cy="17780"/>
+            <a:off x="0" y="2743200"/>
+            <a:ext cx="12191695" cy="25400"/>
           </a:xfrm>
           <a:prstGeom prst="rect">
             <a:avLst/>
@@ -7184,14 +7131,14 @@
       </p:sp>
       <p:sp>
         <p:nvSpPr>
-          <p:cNvPr id="5" name="TextBox 4"/>
+          <p:cNvPr id="3" name="TextBox 2"/>
           <p:cNvSpPr txBox="1"/>
           <p:nvPr/>
         </p:nvSpPr>
         <p:spPr>
           <a:xfrm>
-            <a:off x="685800" y="1737360"/>
-            <a:ext cx="10789920" cy="4754879"/>
+            <a:off x="914400" y="1828800"/>
+            <a:ext cx="10332720" cy="548640"/>
           </a:xfrm>
           <a:prstGeom prst="rect">
             <a:avLst/>
@@ -7206,65 +7153,95 @@
           <a:p>
             <a:pPr algn="l">
               <a:spcAft>
-                <a:spcPts val="1000"/>
-              </a:spcAft>
-            </a:pPr>
-            <a:r>
-              <a:rPr sz="1600" b="0" i="0">
-                <a:solidFill>
-                  <a:srgbClr val="1A1A1A"/>
-                </a:solidFill>
-                <a:latin typeface="Times New Roman"/>
-              </a:rPr>
-              <a:t>–  Single model family (Hubble), single attribute (birthdate), one unlearned checkpoint per method; the recovery findings are on 25 to 44 facts.</a:t>
-            </a:r>
-          </a:p>
-          <a:p>
-            <a:pPr algn="l">
-              <a:spcAft>
-                <a:spcPts val="1000"/>
-              </a:spcAft>
-            </a:pPr>
-            <a:r>
-              <a:rPr sz="1600" b="0" i="0">
-                <a:solidFill>
-                  <a:srgbClr val="1A1A1A"/>
-                </a:solidFill>
-                <a:latin typeface="Times New Roman"/>
-              </a:rPr>
-              <a:t>–  The AWQ backend is a transparent activation-scaling re-implementation isolating the calibration mechanism, not the reference kernel.</a:t>
-            </a:r>
-          </a:p>
-          <a:p>
-            <a:pPr algn="l">
-              <a:spcAft>
-                <a:spcPts val="1000"/>
-              </a:spcAft>
-            </a:pPr>
-            <a:r>
-              <a:rPr sz="1600" b="0" i="0">
-                <a:solidFill>
-                  <a:srgbClr val="1A1A1A"/>
-                </a:solidFill>
-                <a:latin typeface="Times New Roman"/>
-              </a:rPr>
-              <a:t>–  The real-GPTQ cross-check was blocked by an environment/kernel incompatibility, so the calibration-set attack remains an open question rather than a settled result.</a:t>
-            </a:r>
-          </a:p>
-          <a:p>
-            <a:pPr algn="l">
-              <a:spcAft>
-                <a:spcPts val="1000"/>
-              </a:spcAft>
-            </a:pPr>
-            <a:r>
-              <a:rPr sz="1600" b="0" i="0">
-                <a:solidFill>
-                  <a:srgbClr val="1A1A1A"/>
-                </a:solidFill>
-                <a:latin typeface="Times New Roman"/>
-              </a:rPr>
-              <a:t>–  Recovery depth and recovery fraction are complementary; the behavioral fraction is the primary, quantization-isolating signal.</a:t>
+                <a:spcPts val="600"/>
+              </a:spcAft>
+            </a:pPr>
+            <a:r>
+              <a:rPr sz="1300" b="1" i="0">
+                <a:solidFill>
+                  <a:srgbClr val="666666"/>
+                </a:solidFill>
+                <a:latin typeface="Times New Roman"/>
+              </a:rPr>
+              <a:t>PART IV</a:t>
+            </a:r>
+          </a:p>
+        </p:txBody>
+      </p:sp>
+      <p:sp>
+        <p:nvSpPr>
+          <p:cNvPr id="4" name="TextBox 3"/>
+          <p:cNvSpPr txBox="1"/>
+          <p:nvPr/>
+        </p:nvSpPr>
+        <p:spPr>
+          <a:xfrm>
+            <a:off x="914400" y="2194560"/>
+            <a:ext cx="10332720" cy="822960"/>
+          </a:xfrm>
+          <a:prstGeom prst="rect">
+            <a:avLst/>
+          </a:prstGeom>
+          <a:noFill/>
+        </p:spPr>
+        <p:txBody>
+          <a:bodyPr wrap="square" anchor="t">
+            <a:spAutoFit/>
+          </a:bodyPr>
+          <a:lstStyle/>
+          <a:p>
+            <a:pPr algn="l">
+              <a:spcAft>
+                <a:spcPts val="600"/>
+              </a:spcAft>
+            </a:pPr>
+            <a:r>
+              <a:rPr sz="3400" b="1" i="0">
+                <a:solidFill>
+                  <a:srgbClr val="000000"/>
+                </a:solidFill>
+                <a:latin typeface="Times New Roman"/>
+              </a:rPr>
+              <a:t>Takeaways</a:t>
+            </a:r>
+          </a:p>
+        </p:txBody>
+      </p:sp>
+      <p:sp>
+        <p:nvSpPr>
+          <p:cNvPr id="5" name="TextBox 4"/>
+          <p:cNvSpPr txBox="1"/>
+          <p:nvPr/>
+        </p:nvSpPr>
+        <p:spPr>
+          <a:xfrm>
+            <a:off x="914400" y="2926080"/>
+            <a:ext cx="10332720" cy="731520"/>
+          </a:xfrm>
+          <a:prstGeom prst="rect">
+            <a:avLst/>
+          </a:prstGeom>
+          <a:noFill/>
+        </p:spPr>
+        <p:txBody>
+          <a:bodyPr wrap="square" anchor="t">
+            <a:spAutoFit/>
+          </a:bodyPr>
+          <a:lstStyle/>
+          <a:p>
+            <a:pPr algn="l">
+              <a:spcAft>
+                <a:spcPts val="600"/>
+              </a:spcAft>
+            </a:pPr>
+            <a:r>
+              <a:rPr sz="1800" b="0" i="1">
+                <a:solidFill>
+                  <a:srgbClr val="666666"/>
+                </a:solidFill>
+                <a:latin typeface="Times New Roman"/>
+              </a:rPr>
+              <a:t>the complete story, and what is firm vs open</a:t>
             </a:r>
           </a:p>
         </p:txBody>
@@ -7278,6 +7255,233 @@
 </file>
 
 <file path=ppt/slides/slide23.xml><?xml version="1.0" encoding="utf-8"?>
+<p:sld xmlns:a="http://schemas.openxmlformats.org/drawingml/2006/main" xmlns:p="http://schemas.openxmlformats.org/presentationml/2006/main" xmlns:r="http://schemas.openxmlformats.org/officeDocument/2006/relationships">
+  <p:cSld>
+    <p:spTree>
+      <p:nvGrpSpPr>
+        <p:cNvPr id="1" name=""/>
+        <p:cNvGrpSpPr/>
+        <p:nvPr/>
+      </p:nvGrpSpPr>
+      <p:grpSpPr/>
+      <p:sp>
+        <p:nvSpPr>
+          <p:cNvPr id="2" name="TextBox 1"/>
+          <p:cNvSpPr txBox="1"/>
+          <p:nvPr/>
+        </p:nvSpPr>
+        <p:spPr>
+          <a:xfrm>
+            <a:off x="640080" y="384048"/>
+            <a:ext cx="10972800" cy="457200"/>
+          </a:xfrm>
+          <a:prstGeom prst="rect">
+            <a:avLst/>
+          </a:prstGeom>
+          <a:noFill/>
+        </p:spPr>
+        <p:txBody>
+          <a:bodyPr wrap="square" anchor="t">
+            <a:spAutoFit/>
+          </a:bodyPr>
+          <a:lstStyle/>
+          <a:p>
+            <a:pPr algn="l">
+              <a:spcAft>
+                <a:spcPts val="200"/>
+              </a:spcAft>
+            </a:pPr>
+            <a:r>
+              <a:rPr sz="1300" b="1" i="0">
+                <a:solidFill>
+                  <a:srgbClr val="666666"/>
+                </a:solidFill>
+                <a:latin typeface="Times New Roman"/>
+              </a:rPr>
+              <a:t>4 · LIMITATIONS</a:t>
+            </a:r>
+          </a:p>
+        </p:txBody>
+      </p:sp>
+      <p:sp>
+        <p:nvSpPr>
+          <p:cNvPr id="3" name="TextBox 2"/>
+          <p:cNvSpPr txBox="1"/>
+          <p:nvPr/>
+        </p:nvSpPr>
+        <p:spPr>
+          <a:xfrm>
+            <a:off x="640080" y="749808"/>
+            <a:ext cx="11155680" cy="658368"/>
+          </a:xfrm>
+          <a:prstGeom prst="rect">
+            <a:avLst/>
+          </a:prstGeom>
+          <a:noFill/>
+        </p:spPr>
+        <p:txBody>
+          <a:bodyPr wrap="square" anchor="t">
+            <a:spAutoFit/>
+          </a:bodyPr>
+          <a:lstStyle/>
+          <a:p>
+            <a:pPr algn="l">
+              <a:spcAft>
+                <a:spcPts val="600"/>
+              </a:spcAft>
+            </a:pPr>
+            <a:r>
+              <a:rPr sz="3000" b="1" i="0">
+                <a:solidFill>
+                  <a:srgbClr val="000000"/>
+                </a:solidFill>
+                <a:latin typeface="Times New Roman"/>
+              </a:rPr>
+              <a:t>stated honestly</a:t>
+            </a:r>
+          </a:p>
+        </p:txBody>
+      </p:sp>
+      <p:sp>
+        <p:nvSpPr>
+          <p:cNvPr id="4" name="Rectangle 3"/>
+          <p:cNvSpPr/>
+          <p:nvPr/>
+        </p:nvSpPr>
+        <p:spPr>
+          <a:xfrm>
+            <a:off x="658368" y="1481328"/>
+            <a:ext cx="10972800" cy="17780"/>
+          </a:xfrm>
+          <a:prstGeom prst="rect">
+            <a:avLst/>
+          </a:prstGeom>
+          <a:solidFill>
+            <a:srgbClr val="000000"/>
+          </a:solidFill>
+          <a:ln>
+            <a:noFill/>
+          </a:ln>
+          <a:effectLst/>
+        </p:spPr>
+        <p:style>
+          <a:lnRef idx="1">
+            <a:schemeClr val="accent1"/>
+          </a:lnRef>
+          <a:fillRef idx="3">
+            <a:schemeClr val="accent1"/>
+          </a:fillRef>
+          <a:effectRef idx="2">
+            <a:schemeClr val="accent1"/>
+          </a:effectRef>
+          <a:fontRef idx="minor">
+            <a:schemeClr val="lt1"/>
+          </a:fontRef>
+        </p:style>
+        <p:txBody>
+          <a:bodyPr rtlCol="0" anchor="ctr"/>
+          <a:lstStyle/>
+          <a:p>
+            <a:pPr algn="ctr"/>
+          </a:p>
+        </p:txBody>
+      </p:sp>
+      <p:sp>
+        <p:nvSpPr>
+          <p:cNvPr id="5" name="TextBox 4"/>
+          <p:cNvSpPr txBox="1"/>
+          <p:nvPr/>
+        </p:nvSpPr>
+        <p:spPr>
+          <a:xfrm>
+            <a:off x="685800" y="1737360"/>
+            <a:ext cx="10789920" cy="4754879"/>
+          </a:xfrm>
+          <a:prstGeom prst="rect">
+            <a:avLst/>
+          </a:prstGeom>
+          <a:noFill/>
+        </p:spPr>
+        <p:txBody>
+          <a:bodyPr wrap="square" anchor="t">
+            <a:spAutoFit/>
+          </a:bodyPr>
+          <a:lstStyle/>
+          <a:p>
+            <a:pPr algn="l">
+              <a:spcAft>
+                <a:spcPts val="1000"/>
+              </a:spcAft>
+            </a:pPr>
+            <a:r>
+              <a:rPr sz="1600" b="0" i="0">
+                <a:solidFill>
+                  <a:srgbClr val="1A1A1A"/>
+                </a:solidFill>
+                <a:latin typeface="Times New Roman"/>
+              </a:rPr>
+              <a:t>–  Single model family (Hubble), single attribute (birthdate), one unlearned checkpoint per method; the recovery findings are on 25 to 44 facts.</a:t>
+            </a:r>
+          </a:p>
+          <a:p>
+            <a:pPr algn="l">
+              <a:spcAft>
+                <a:spcPts val="1000"/>
+              </a:spcAft>
+            </a:pPr>
+            <a:r>
+              <a:rPr sz="1600" b="0" i="0">
+                <a:solidFill>
+                  <a:srgbClr val="1A1A1A"/>
+                </a:solidFill>
+                <a:latin typeface="Times New Roman"/>
+              </a:rPr>
+              <a:t>–  The AWQ backend is a transparent activation-scaling re-implementation isolating the calibration mechanism, not the reference kernel.</a:t>
+            </a:r>
+          </a:p>
+          <a:p>
+            <a:pPr algn="l">
+              <a:spcAft>
+                <a:spcPts val="1000"/>
+              </a:spcAft>
+            </a:pPr>
+            <a:r>
+              <a:rPr sz="1600" b="0" i="0">
+                <a:solidFill>
+                  <a:srgbClr val="1A1A1A"/>
+                </a:solidFill>
+                <a:latin typeface="Times New Roman"/>
+              </a:rPr>
+              <a:t>–  The real-GPTQ cross-check was blocked by an environment/kernel incompatibility, so the calibration-set attack remains an open question rather than a settled result.</a:t>
+            </a:r>
+          </a:p>
+          <a:p>
+            <a:pPr algn="l">
+              <a:spcAft>
+                <a:spcPts val="1000"/>
+              </a:spcAft>
+            </a:pPr>
+            <a:r>
+              <a:rPr sz="1600" b="0" i="0">
+                <a:solidFill>
+                  <a:srgbClr val="1A1A1A"/>
+                </a:solidFill>
+                <a:latin typeface="Times New Roman"/>
+              </a:rPr>
+              <a:t>–  Recovery depth and recovery fraction are complementary; the behavioral fraction is the primary, quantization-isolating signal.</a:t>
+            </a:r>
+          </a:p>
+        </p:txBody>
+      </p:sp>
+    </p:spTree>
+  </p:cSld>
+  <p:clrMapOvr>
+    <a:masterClrMapping/>
+  </p:clrMapOvr>
+</p:sld>
+</file>
+
+<file path=ppt/slides/slide24.xml><?xml version="1.0" encoding="utf-8"?>
 <p:sld xmlns:a="http://schemas.openxmlformats.org/drawingml/2006/main" xmlns:p="http://schemas.openxmlformats.org/presentationml/2006/main" xmlns:r="http://schemas.openxmlformats.org/officeDocument/2006/relationships">
   <p:cSld>
     <p:spTree>

</xml_diff>